<commit_message>
Add slide transitions to Spa-Francorchamps briefing
- Slide 1 (Title): Fade — ouverture douce
- Slides 2-5, 7-8: Push left — flux continu vers l'avant
- Slide 6 (ONSS): Cover left — effet de recouvrement pour marquer l'importance
- Slide 9 (Questions): Fade slow — clôture élégante

Co-Authored-By: Claude Sonnet 4.6 <noreply@anthropic.com>
Claude-Session: https://claude.ai/code/session_01Vak9wXe4fzMCWcT6wEiKXC
</commit_message>
<xml_diff>
--- a/Briefing_SpaFrancorchamps_v2.pptx
+++ b/Briefing_SpaFrancorchamps_v2.pptx
@@ -1851,6 +1851,9 @@
   <p:clrMapOvr>
     <a:masterClrMapping/>
   </p:clrMapOvr>
+  <p:transition spd="med">
+    <p:fade thruBlk="0"/>
+  </p:transition>
 </p:sld>
 </file>
 
@@ -2251,6 +2254,9 @@
   <p:clrMapOvr>
     <a:masterClrMapping/>
   </p:clrMapOvr>
+  <p:transition spd="med">
+    <p:push dir="l"/>
+  </p:transition>
 </p:sld>
 </file>
 
@@ -3360,6 +3366,9 @@
   <p:clrMapOvr>
     <a:masterClrMapping/>
   </p:clrMapOvr>
+  <p:transition spd="med">
+    <p:push dir="l"/>
+  </p:transition>
 </p:sld>
 </file>
 
@@ -4146,6 +4155,9 @@
   <p:clrMapOvr>
     <a:masterClrMapping/>
   </p:clrMapOvr>
+  <p:transition spd="med">
+    <p:push dir="l"/>
+  </p:transition>
 </p:sld>
 </file>
 
@@ -5044,6 +5056,9 @@
   <p:clrMapOvr>
     <a:masterClrMapping/>
   </p:clrMapOvr>
+  <p:transition spd="med">
+    <p:push dir="l"/>
+  </p:transition>
 </p:sld>
 </file>
 
@@ -5950,6 +5965,9 @@
   <p:clrMapOvr>
     <a:masterClrMapping/>
   </p:clrMapOvr>
+  <p:transition spd="med">
+    <p:cover dir="l"/>
+  </p:transition>
 </p:sld>
 </file>
 
@@ -6617,6 +6635,9 @@
   <p:clrMapOvr>
     <a:masterClrMapping/>
   </p:clrMapOvr>
+  <p:transition spd="med">
+    <p:push dir="l"/>
+  </p:transition>
 </p:sld>
 </file>
 
@@ -7672,6 +7693,9 @@
   <p:clrMapOvr>
     <a:masterClrMapping/>
   </p:clrMapOvr>
+  <p:transition spd="med">
+    <p:push dir="l"/>
+  </p:transition>
 </p:sld>
 </file>
 
@@ -7980,6 +8004,9 @@
   <p:clrMapOvr>
     <a:masterClrMapping/>
   </p:clrMapOvr>
+  <p:transition spd="slow">
+    <p:fade thruBlk="0"/>
+  </p:transition>
 </p:sld>
 </file>
 

</xml_diff>